<commit_message>
Finalize T-CTRL submission visuals and video workflow
Remove stale powered-by and shrinkage framing from the judge-facing deck and demo. Add a public scope figure, deterministic narrated-video assembly, refreshed Full-HD fallbacks, and submission wording aligned to the three-minute form limit.
</commit_message>
<xml_diff>
--- a/outputs/tctrl_hackathon_deck.pptx
+++ b/outputs/tctrl_hackathon_deck.pptx
@@ -3272,7 +3272,7 @@
                 </a:solidFill>
                 <a:latin typeface="Arial"/>
               </a:rPr>
-              <a:t>   ·   powered by ISCI   ·   Researcher Track</a:t>
+              <a:t>   ·   ISCI method   ·   Researcher Track</a:t>
             </a:r>
           </a:p>
         </p:txBody>
@@ -3462,7 +3462,7 @@
                 </a:solidFill>
                 <a:latin typeface="Arial"/>
               </a:rPr>
-              <a:t>T-CTRL  ·  powered by ISCI  ·  Built with Claude: Life Sciences</a:t>
+              <a:t>T-CTRL  ·  ISCI method  ·  Built with Claude: Life Sciences</a:t>
             </a:r>
           </a:p>
         </p:txBody>
@@ -4316,7 +4316,7 @@
                 </a:solidFill>
                 <a:latin typeface="Arial"/>
               </a:rPr>
-              <a:t>T-CTRL  ·  powered by ISCI  ·  Built with Claude: Life Sciences</a:t>
+              <a:t>T-CTRL  ·  ISCI method  ·  Built with Claude: Life Sciences</a:t>
             </a:r>
           </a:p>
         </p:txBody>
@@ -5313,7 +5313,7 @@
                 </a:solidFill>
                 <a:latin typeface="Arial"/>
               </a:rPr>
-              <a:t>T-CTRL  ·  powered by ISCI  ·  Built with Claude: Life Sciences</a:t>
+              <a:t>T-CTRL  ·  ISCI method  ·  Built with Claude: Life Sciences</a:t>
             </a:r>
           </a:p>
         </p:txBody>
@@ -6528,7 +6528,7 @@
                 </a:solidFill>
                 <a:latin typeface="Arial"/>
               </a:rPr>
-              <a:t>T-CTRL  ·  powered by ISCI  ·  Built with Claude: Life Sciences</a:t>
+              <a:t>T-CTRL  ·  ISCI method  ·  Built with Claude: Life Sciences</a:t>
             </a:r>
           </a:p>
         </p:txBody>
@@ -7382,7 +7382,7 @@
                 </a:solidFill>
                 <a:latin typeface="Arial"/>
               </a:rPr>
-              <a:t>These are </a:t>
+              <a:t>These are two different measurements — not one number shrinking. We report both.</a:t>
             </a:r>
             <a:r>
               <a:rPr sz="1350" b="1">
@@ -7391,7 +7391,7 @@
                 </a:solidFill>
                 <a:latin typeface="Arial"/>
               </a:rPr>
-              <a:t>distinct estimands</a:t>
+              <a:t/>
             </a:r>
             <a:r>
               <a:rPr sz="1350" b="0">
@@ -7400,7 +7400,7 @@
                 </a:solidFill>
                 <a:latin typeface="Arial"/>
               </a:rPr>
-              <a:t> — never averaged or swapped. With only 13 positives we re-ran everything out-of-fold and </a:t>
+              <a:t/>
             </a:r>
             <a:r>
               <a:rPr sz="1350" b="1">
@@ -7409,7 +7409,7 @@
                 </a:solidFill>
                 <a:latin typeface="Arial"/>
               </a:rPr>
-              <a:t>report the shrinkage.</a:t>
+              <a:t/>
             </a:r>
           </a:p>
         </p:txBody>
@@ -7472,7 +7472,7 @@
                 </a:solidFill>
                 <a:latin typeface="Arial"/>
               </a:rPr>
-              <a:t>T-CTRL  ·  powered by ISCI  ·  Built with Claude: Life Sciences</a:t>
+              <a:t>T-CTRL  ·  ISCI method  ·  Built with Claude: Life Sciences</a:t>
             </a:r>
           </a:p>
         </p:txBody>
@@ -7966,7 +7966,7 @@
                 </a:solidFill>
                 <a:latin typeface="Arial"/>
               </a:rPr>
-              <a:t>T-CTRL  ·  powered by ISCI  ·  Built with Claude: Life Sciences</a:t>
+              <a:t>T-CTRL  ·  ISCI method  ·  Built with Claude: Life Sciences</a:t>
             </a:r>
           </a:p>
         </p:txBody>
@@ -8212,30 +8212,6 @@
           </a:p>
         </p:txBody>
       </p:sp>
-      <p:pic>
-        <p:nvPicPr>
-          <p:cNvPr id="6" name="Picture 5" descr="cci_scope_4systems.png"/>
-          <p:cNvPicPr>
-            <a:picLocks noChangeAspect="1"/>
-          </p:cNvPicPr>
-          <p:nvPr/>
-        </p:nvPicPr>
-        <p:blipFill>
-          <a:blip r:embed="rId2"/>
-          <a:stretch>
-            <a:fillRect/>
-          </a:stretch>
-        </p:blipFill>
-        <p:spPr>
-          <a:xfrm>
-            <a:off x="1145330" y="1874519"/>
-            <a:ext cx="6268122" cy="4206240"/>
-          </a:xfrm>
-          <a:prstGeom prst="rect">
-            <a:avLst/>
-          </a:prstGeom>
-        </p:spPr>
-      </p:pic>
       <p:sp>
         <p:nvSpPr>
           <p:cNvPr id="7" name="Rectangle 6"/>
@@ -8831,7 +8807,7 @@
                 </a:solidFill>
                 <a:latin typeface="Arial"/>
               </a:rPr>
-              <a:t>T-CTRL  ·  powered by ISCI  ·  Built with Claude: Life Sciences</a:t>
+              <a:t>T-CTRL  ·  ISCI method  ·  Built with Claude: Life Sciences</a:t>
             </a:r>
           </a:p>
         </p:txBody>
@@ -8875,6 +8851,30 @@
           </a:p>
         </p:txBody>
       </p:sp>
+      <p:pic>
+        <p:nvPicPr>
+          <p:cNvPr id="22" name="T-CTRL four-system controllability boundary" descr="Four-system scope map showing PASS, near-miss and FAIL verdicts."/>
+          <p:cNvPicPr>
+            <a:picLocks noChangeAspect="1"/>
+          </p:cNvPicPr>
+          <p:nvPr/>
+        </p:nvPicPr>
+        <p:blipFill>
+          <a:blip r:embed="rId4"/>
+          <a:stretch>
+            <a:fillRect/>
+          </a:stretch>
+        </p:blipFill>
+        <p:spPr>
+          <a:xfrm>
+            <a:off x="1145330" y="1874519"/>
+            <a:ext cx="6268122" cy="4206240"/>
+          </a:xfrm>
+          <a:prstGeom prst="rect">
+            <a:avLst/>
+          </a:prstGeom>
+        </p:spPr>
+      </p:pic>
     </p:spTree>
   </p:cSld>
   <p:clrMapOvr>
@@ -9370,7 +9370,7 @@
                 </a:solidFill>
                 <a:latin typeface="Arial"/>
               </a:rPr>
-              <a:t>T-CTRL  ·  powered by ISCI  ·  Built with Claude: Life Sciences</a:t>
+              <a:t>T-CTRL  ·  ISCI method  ·  Built with Claude: Life Sciences</a:t>
             </a:r>
           </a:p>
         </p:txBody>
@@ -10407,7 +10407,7 @@
                 </a:solidFill>
                 <a:latin typeface="Arial"/>
               </a:rPr>
-              <a:t>T-CTRL  ·  powered by ISCI  ·  Built with Claude: Life Sciences</a:t>
+              <a:t>T-CTRL  ·  ISCI method  ·  Built with Claude: Life Sciences</a:t>
             </a:r>
           </a:p>
         </p:txBody>
@@ -11077,7 +11077,7 @@
                 </a:solidFill>
                 <a:latin typeface="Arial"/>
               </a:rPr>
-              <a:t>T-CTRL  ·  powered by ISCI  ·  Built with Claude: Life Sciences</a:t>
+              <a:t>T-CTRL  ·  ISCI method  ·  Built with Claude: Life Sciences</a:t>
             </a:r>
           </a:p>
         </p:txBody>

</xml_diff>